<commit_message>
fix(apresentacao): tira o texto de cima do rodape e acerta a contagem de slides
Tres defeitos que so aparecem na projecao. O titulo de 28 pt quebrava em duas
linhas e vazava de uma caixa de 0,9 polegada em dois slides. A frase de fecho
dos slides 5, 7 e 8 ocupava a mesma faixa do rodape. E o gerador anunciava 15
slides num arquivo de 13, porque somava dois a mais sem motivo. Os seis nomes
do grupo passam a sair em duas linhas, que em uma so estouram a caixa.
</commit_message>
<xml_diff>
--- a/PermaneIA-Apresentacao.pptx
+++ b/PermaneIA-Apresentacao.pptx
@@ -2088,24 +2088,24 @@
         </p:nvSpPr>
         <p:spPr>
           <a:xfrm>
-            <a:off x="640080" y="5623560"/>
-            <a:ext cx="10972800" cy="365760"/>
-          </a:xfrm>
-          <a:prstGeom prst="rect">
-            <a:avLst/>
-          </a:prstGeom>
-          <a:noFill/>
-          <a:ln/>
-        </p:spPr>
-        <p:txBody>
-          <a:bodyPr wrap="square" rtlCol="0" anchor="ctr"/>
-          <a:lstStyle/>
-          <a:p>
-            <a:pPr indent="0" marL="0">
-              <a:buNone/>
-            </a:pPr>
-            <a:r>
-              <a:rPr lang="en-US" sz="1300" dirty="0">
+            <a:off x="640080" y="5486400"/>
+            <a:ext cx="10972800" cy="475488"/>
+          </a:xfrm>
+          <a:prstGeom prst="rect">
+            <a:avLst/>
+          </a:prstGeom>
+          <a:noFill/>
+          <a:ln/>
+        </p:spPr>
+        <p:txBody>
+          <a:bodyPr wrap="square" rtlCol="0" anchor="ctr"/>
+          <a:lstStyle/>
+          <a:p>
+            <a:pPr indent="0" marL="0">
+              <a:buNone/>
+            </a:pPr>
+            <a:r>
+              <a:rPr lang="en-US" sz="1150" dirty="0">
                 <a:solidFill>
                   <a:srgbClr val="9FADBE"/>
                 </a:solidFill>
@@ -2113,9 +2113,26 @@
                 <a:ea typeface="Verdana" pitchFamily="34" charset="-122"/>
                 <a:cs typeface="Verdana" pitchFamily="34" charset="-120"/>
               </a:rPr>
-              <a:t>Camila Pereira Raimundo · Fabrício Júnio Almeida Dias · Kauã Limão Nunes · Luan Padilha Miranda</a:t>
-            </a:r>
-            <a:endParaRPr lang="en-US" sz="1300" dirty="0"/>
+              <a:t>Camila Pereira Raimundo · Fabrício Júnio Almeida Dias · Ian Felipe Amaral Oliveira Silva</a:t>
+            </a:r>
+            <a:endParaRPr lang="en-US" sz="1150" dirty="0"/>
+          </a:p>
+          <a:p>
+            <a:pPr indent="0" marL="0">
+              <a:buNone/>
+            </a:pPr>
+            <a:r>
+              <a:rPr lang="en-US" sz="1150" dirty="0">
+                <a:solidFill>
+                  <a:srgbClr val="9FADBE"/>
+                </a:solidFill>
+                <a:latin typeface="Verdana" pitchFamily="34" charset="0"/>
+                <a:ea typeface="Verdana" pitchFamily="34" charset="-122"/>
+                <a:cs typeface="Verdana" pitchFamily="34" charset="-120"/>
+              </a:rPr>
+              <a:t>Kauã Limão Nunes · Luan Padilha Miranda · Lucas Massamiti Tsuji</a:t>
+            </a:r>
+            <a:endParaRPr lang="en-US" sz="1150" dirty="0"/>
           </a:p>
         </p:txBody>
       </p:sp>
@@ -3791,8 +3808,8 @@
         </p:nvSpPr>
         <p:spPr>
           <a:xfrm>
-            <a:off x="548640" y="6400800"/>
-            <a:ext cx="7315200" cy="274320"/>
+            <a:off x="548640" y="6510528"/>
+            <a:ext cx="7315200" cy="256032"/>
           </a:xfrm>
           <a:prstGeom prst="rect">
             <a:avLst/>
@@ -3830,8 +3847,8 @@
         </p:nvSpPr>
         <p:spPr>
           <a:xfrm>
-            <a:off x="11185855" y="6400800"/>
-            <a:ext cx="457200" cy="274320"/>
+            <a:off x="11185855" y="6510528"/>
+            <a:ext cx="457200" cy="256032"/>
           </a:xfrm>
           <a:prstGeom prst="rect">
             <a:avLst/>
@@ -4408,8 +4425,8 @@
         </p:nvSpPr>
         <p:spPr>
           <a:xfrm>
-            <a:off x="548640" y="6400800"/>
-            <a:ext cx="7315200" cy="274320"/>
+            <a:off x="548640" y="6510528"/>
+            <a:ext cx="7315200" cy="256032"/>
           </a:xfrm>
           <a:prstGeom prst="rect">
             <a:avLst/>
@@ -4447,8 +4464,8 @@
         </p:nvSpPr>
         <p:spPr>
           <a:xfrm>
-            <a:off x="11185855" y="6400800"/>
-            <a:ext cx="457200" cy="274320"/>
+            <a:off x="11185855" y="6510528"/>
+            <a:ext cx="457200" cy="256032"/>
           </a:xfrm>
           <a:prstGeom prst="rect">
             <a:avLst/>
@@ -5331,8 +5348,8 @@
         </p:nvSpPr>
         <p:spPr>
           <a:xfrm>
-            <a:off x="548640" y="6400800"/>
-            <a:ext cx="7315200" cy="274320"/>
+            <a:off x="548640" y="6510528"/>
+            <a:ext cx="7315200" cy="256032"/>
           </a:xfrm>
           <a:prstGeom prst="rect">
             <a:avLst/>
@@ -5370,8 +5387,8 @@
         </p:nvSpPr>
         <p:spPr>
           <a:xfrm>
-            <a:off x="11185855" y="6400800"/>
-            <a:ext cx="457200" cy="274320"/>
+            <a:off x="11185855" y="6510528"/>
+            <a:ext cx="457200" cy="256032"/>
           </a:xfrm>
           <a:prstGeom prst="rect">
             <a:avLst/>
@@ -5617,24 +5634,24 @@
         </p:nvSpPr>
         <p:spPr>
           <a:xfrm>
-            <a:off x="640080" y="5623560"/>
-            <a:ext cx="10972800" cy="365760"/>
-          </a:xfrm>
-          <a:prstGeom prst="rect">
-            <a:avLst/>
-          </a:prstGeom>
-          <a:noFill/>
-          <a:ln/>
-        </p:spPr>
-        <p:txBody>
-          <a:bodyPr wrap="square" rtlCol="0" anchor="ctr"/>
-          <a:lstStyle/>
-          <a:p>
-            <a:pPr indent="0" marL="0">
-              <a:buNone/>
-            </a:pPr>
-            <a:r>
-              <a:rPr lang="en-US" sz="1250" dirty="0">
+            <a:off x="640080" y="5486400"/>
+            <a:ext cx="10972800" cy="475488"/>
+          </a:xfrm>
+          <a:prstGeom prst="rect">
+            <a:avLst/>
+          </a:prstGeom>
+          <a:noFill/>
+          <a:ln/>
+        </p:spPr>
+        <p:txBody>
+          <a:bodyPr wrap="square" rtlCol="0" anchor="ctr"/>
+          <a:lstStyle/>
+          <a:p>
+            <a:pPr indent="0" marL="0">
+              <a:buNone/>
+            </a:pPr>
+            <a:r>
+              <a:rPr lang="en-US" sz="1150" dirty="0">
                 <a:solidFill>
                   <a:srgbClr val="9FADBE"/>
                 </a:solidFill>
@@ -5642,9 +5659,26 @@
                 <a:ea typeface="Verdana" pitchFamily="34" charset="-122"/>
                 <a:cs typeface="Verdana" pitchFamily="34" charset="-120"/>
               </a:rPr>
-              <a:t>Camila Pereira Raimundo · Fabrício Júnio Almeida Dias · Kauã Limão Nunes · Luan Padilha Miranda</a:t>
-            </a:r>
-            <a:endParaRPr lang="en-US" sz="1250" dirty="0"/>
+              <a:t>Camila Pereira Raimundo · Fabrício Júnio Almeida Dias · Ian Felipe Amaral Oliveira Silva</a:t>
+            </a:r>
+            <a:endParaRPr lang="en-US" sz="1150" dirty="0"/>
+          </a:p>
+          <a:p>
+            <a:pPr indent="0" marL="0">
+              <a:buNone/>
+            </a:pPr>
+            <a:r>
+              <a:rPr lang="en-US" sz="1150" dirty="0">
+                <a:solidFill>
+                  <a:srgbClr val="9FADBE"/>
+                </a:solidFill>
+                <a:latin typeface="Verdana" pitchFamily="34" charset="0"/>
+                <a:ea typeface="Verdana" pitchFamily="34" charset="-122"/>
+                <a:cs typeface="Verdana" pitchFamily="34" charset="-120"/>
+              </a:rPr>
+              <a:t>Kauã Limão Nunes · Luan Padilha Miranda · Lucas Massamiti Tsuji</a:t>
+            </a:r>
+            <a:endParaRPr lang="en-US" sz="1150" dirty="0"/>
           </a:p>
         </p:txBody>
       </p:sp>
@@ -6306,8 +6340,8 @@
         </p:nvSpPr>
         <p:spPr>
           <a:xfrm>
-            <a:off x="548640" y="6400800"/>
-            <a:ext cx="7315200" cy="274320"/>
+            <a:off x="548640" y="6510528"/>
+            <a:ext cx="7315200" cy="256032"/>
           </a:xfrm>
           <a:prstGeom prst="rect">
             <a:avLst/>
@@ -6345,8 +6379,8 @@
         </p:nvSpPr>
         <p:spPr>
           <a:xfrm>
-            <a:off x="11185855" y="6400800"/>
-            <a:ext cx="457200" cy="274320"/>
+            <a:off x="11185855" y="6510528"/>
+            <a:ext cx="457200" cy="256032"/>
           </a:xfrm>
           <a:prstGeom prst="rect">
             <a:avLst/>
@@ -6846,8 +6880,8 @@
         </p:nvSpPr>
         <p:spPr>
           <a:xfrm>
-            <a:off x="548640" y="6400800"/>
-            <a:ext cx="7315200" cy="274320"/>
+            <a:off x="548640" y="6510528"/>
+            <a:ext cx="7315200" cy="256032"/>
           </a:xfrm>
           <a:prstGeom prst="rect">
             <a:avLst/>
@@ -6885,8 +6919,8 @@
         </p:nvSpPr>
         <p:spPr>
           <a:xfrm>
-            <a:off x="11185855" y="6400800"/>
-            <a:ext cx="457200" cy="274320"/>
+            <a:off x="11185855" y="6510528"/>
+            <a:ext cx="457200" cy="256032"/>
           </a:xfrm>
           <a:prstGeom prst="rect">
             <a:avLst/>
@@ -8750,8 +8784,8 @@
         </p:nvSpPr>
         <p:spPr>
           <a:xfrm>
-            <a:off x="548640" y="6400800"/>
-            <a:ext cx="7315200" cy="274320"/>
+            <a:off x="548640" y="6510528"/>
+            <a:ext cx="7315200" cy="256032"/>
           </a:xfrm>
           <a:prstGeom prst="rect">
             <a:avLst/>
@@ -8789,8 +8823,8 @@
         </p:nvSpPr>
         <p:spPr>
           <a:xfrm>
-            <a:off x="11185855" y="6400800"/>
-            <a:ext cx="457200" cy="274320"/>
+            <a:off x="11185855" y="6510528"/>
+            <a:ext cx="457200" cy="256032"/>
           </a:xfrm>
           <a:prstGeom prst="rect">
             <a:avLst/>
@@ -8900,7 +8934,7 @@
         <p:spPr>
           <a:xfrm>
             <a:off x="640080" y="777240"/>
-            <a:ext cx="10972800" cy="822960"/>
+            <a:ext cx="10972800" cy="1005840"/>
           </a:xfrm>
           <a:prstGeom prst="rect">
             <a:avLst/>
@@ -9370,7 +9404,7 @@
         </p:nvSpPr>
         <p:spPr>
           <a:xfrm>
-            <a:off x="640080" y="6263640"/>
+            <a:off x="640080" y="6053328"/>
             <a:ext cx="10972800" cy="320040"/>
           </a:xfrm>
           <a:prstGeom prst="rect">
@@ -9409,8 +9443,8 @@
         </p:nvSpPr>
         <p:spPr>
           <a:xfrm>
-            <a:off x="548640" y="6400800"/>
-            <a:ext cx="7315200" cy="274320"/>
+            <a:off x="548640" y="6510528"/>
+            <a:ext cx="7315200" cy="256032"/>
           </a:xfrm>
           <a:prstGeom prst="rect">
             <a:avLst/>
@@ -9448,8 +9482,8 @@
         </p:nvSpPr>
         <p:spPr>
           <a:xfrm>
-            <a:off x="11185855" y="6400800"/>
-            <a:ext cx="457200" cy="274320"/>
+            <a:off x="11185855" y="6510528"/>
+            <a:ext cx="457200" cy="256032"/>
           </a:xfrm>
           <a:prstGeom prst="rect">
             <a:avLst/>
@@ -9559,7 +9593,7 @@
         <p:spPr>
           <a:xfrm>
             <a:off x="640080" y="777240"/>
-            <a:ext cx="10972800" cy="822960"/>
+            <a:ext cx="10972800" cy="1005840"/>
           </a:xfrm>
           <a:prstGeom prst="rect">
             <a:avLst/>
@@ -10119,8 +10153,8 @@
         </p:nvSpPr>
         <p:spPr>
           <a:xfrm>
-            <a:off x="548640" y="6400800"/>
-            <a:ext cx="7315200" cy="274320"/>
+            <a:off x="548640" y="6510528"/>
+            <a:ext cx="7315200" cy="256032"/>
           </a:xfrm>
           <a:prstGeom prst="rect">
             <a:avLst/>
@@ -10158,8 +10192,8 @@
         </p:nvSpPr>
         <p:spPr>
           <a:xfrm>
-            <a:off x="11185855" y="6400800"/>
-            <a:ext cx="457200" cy="274320"/>
+            <a:off x="11185855" y="6510528"/>
+            <a:ext cx="457200" cy="256032"/>
           </a:xfrm>
           <a:prstGeom prst="rect">
             <a:avLst/>
@@ -10748,7 +10782,7 @@
         </p:nvSpPr>
         <p:spPr>
           <a:xfrm>
-            <a:off x="640080" y="6263640"/>
+            <a:off x="640080" y="6035040"/>
             <a:ext cx="10972800" cy="320040"/>
           </a:xfrm>
           <a:prstGeom prst="rect">
@@ -10787,8 +10821,8 @@
         </p:nvSpPr>
         <p:spPr>
           <a:xfrm>
-            <a:off x="548640" y="6400800"/>
-            <a:ext cx="7315200" cy="274320"/>
+            <a:off x="548640" y="6510528"/>
+            <a:ext cx="7315200" cy="256032"/>
           </a:xfrm>
           <a:prstGeom prst="rect">
             <a:avLst/>
@@ -10826,8 +10860,8 @@
         </p:nvSpPr>
         <p:spPr>
           <a:xfrm>
-            <a:off x="11185855" y="6400800"/>
-            <a:ext cx="457200" cy="274320"/>
+            <a:off x="11185855" y="6510528"/>
+            <a:ext cx="457200" cy="256032"/>
           </a:xfrm>
           <a:prstGeom prst="rect">
             <a:avLst/>
@@ -11416,7 +11450,7 @@
         </p:nvSpPr>
         <p:spPr>
           <a:xfrm>
-            <a:off x="640080" y="6309360"/>
+            <a:off x="640080" y="6199632"/>
             <a:ext cx="10972800" cy="320040"/>
           </a:xfrm>
           <a:prstGeom prst="rect">
@@ -11455,8 +11489,8 @@
         </p:nvSpPr>
         <p:spPr>
           <a:xfrm>
-            <a:off x="548640" y="6400800"/>
-            <a:ext cx="7315200" cy="274320"/>
+            <a:off x="548640" y="6510528"/>
+            <a:ext cx="7315200" cy="256032"/>
           </a:xfrm>
           <a:prstGeom prst="rect">
             <a:avLst/>
@@ -11494,8 +11528,8 @@
         </p:nvSpPr>
         <p:spPr>
           <a:xfrm>
-            <a:off x="11185855" y="6400800"/>
-            <a:ext cx="457200" cy="274320"/>
+            <a:off x="11185855" y="6510528"/>
+            <a:ext cx="457200" cy="256032"/>
           </a:xfrm>
           <a:prstGeom prst="rect">
             <a:avLst/>
@@ -12200,8 +12234,8 @@
         </p:nvSpPr>
         <p:spPr>
           <a:xfrm>
-            <a:off x="548640" y="6400800"/>
-            <a:ext cx="7315200" cy="274320"/>
+            <a:off x="548640" y="6510528"/>
+            <a:ext cx="7315200" cy="256032"/>
           </a:xfrm>
           <a:prstGeom prst="rect">
             <a:avLst/>
@@ -12239,8 +12273,8 @@
         </p:nvSpPr>
         <p:spPr>
           <a:xfrm>
-            <a:off x="11185855" y="6400800"/>
-            <a:ext cx="457200" cy="274320"/>
+            <a:off x="11185855" y="6510528"/>
+            <a:ext cx="457200" cy="256032"/>
           </a:xfrm>
           <a:prstGeom prst="rect">
             <a:avLst/>

</xml_diff>

<commit_message>
docs(pesquisa): corrige indicadores e delimita evidências acadêmicas
</commit_message>
<xml_diff>
--- a/PermaneIA-Apresentacao.pptx
+++ b/PermaneIA-Apresentacao.pptx
@@ -1043,7 +1043,9 @@
           <a:p>
             <a:r>
               <a:rPr lang="en-US" dirty="0"/>
-              <a:t/>
+              <a:t>64,7%: de desistência acumulada na rede privada, no ciclo 2020–2024. Instituto Semesp, Mapa do Ensino Superior 2026. Indicadores de trajetória, base Inep. https://www.semesp.org.br/mapa/edicao-16/brasil/
+68,1%: de desistência acumulada no EAD privado, no ciclo 2020–2024. Instituto Semesp, Mapa do Ensino Superior 2026. Indicadores de trajetória, base Inep. https://www.semesp.org.br/mapa/edicao-16/brasil/
+49%: dos ingressantes em bacharelados no Brasil concluem até três anos após a duração prevista. OCDE, Education at a Glance 2025, nota do Brasil, tabela B5.1. https://www.oecd.org/en/publications/education-at-a-glance-2025_1a3543e2-en/brazil_d42263a0-en.html</a:t>
             </a:r>
             <a:endParaRPr lang="en-US" dirty="0"/>
           </a:p>
@@ -6582,7 +6584,7 @@
                 <a:ea typeface="Verdana" pitchFamily="34" charset="-122"/>
                 <a:cs typeface="Verdana" pitchFamily="34" charset="-120"/>
               </a:rPr>
-              <a:t>Mais da metade não termina o que começou</a:t>
+              <a:t>Permanência exige acompanhamento</a:t>
             </a:r>
             <a:endParaRPr lang="en-US" sz="2800" dirty="0"/>
           </a:p>
@@ -6624,7 +6626,7 @@
                 <a:ea typeface="Verdana" pitchFamily="34" charset="-122"/>
                 <a:cs typeface="Verdana" pitchFamily="34" charset="-120"/>
               </a:rPr>
-              <a:t>A evasão no ensino superior brasileiro não é um risco distante: é o desfecho mais provável para boa parte de quem entra. E o abandono não começa quando a nota cai. Começa quando o aluno para de aparecer.</a:t>
+              <a:t>Os indicadores abaixo usam populações e períodos diferentes. Eles contextualizam o problema; não medem a eficácia do PermaneIA. O alerta fuzzy é uma heurística acadêmica, ainda sem validação preditiva com alunos reais.</a:t>
             </a:r>
             <a:endParaRPr lang="en-US" sz="1500" dirty="0"/>
           </a:p>
@@ -6639,7 +6641,7 @@
         <p:spPr>
           <a:xfrm>
             <a:off x="640080" y="3200400"/>
-            <a:ext cx="2560320" cy="1737360"/>
+            <a:ext cx="3474720" cy="1737360"/>
           </a:xfrm>
           <a:prstGeom prst="roundRect">
             <a:avLst>
@@ -6666,7 +6668,7 @@
         <p:spPr>
           <a:xfrm>
             <a:off x="640080" y="3401568"/>
-            <a:ext cx="2560320" cy="777240"/>
+            <a:ext cx="3474720" cy="777240"/>
           </a:xfrm>
           <a:prstGeom prst="rect">
             <a:avLst/>
@@ -6690,7 +6692,7 @@
                 <a:ea typeface="Verdana" pitchFamily="34" charset="-122"/>
                 <a:cs typeface="Verdana" pitchFamily="34" charset="-120"/>
               </a:rPr>
-              <a:t>57,2%</a:t>
+              <a:t>64,7%</a:t>
             </a:r>
             <a:endParaRPr lang="en-US" sz="3400" dirty="0"/>
           </a:p>
@@ -6705,7 +6707,7 @@
         <p:spPr>
           <a:xfrm>
             <a:off x="777240" y="4187952"/>
-            <a:ext cx="2286000" cy="640080"/>
+            <a:ext cx="3200400" cy="640080"/>
           </a:xfrm>
           <a:prstGeom prst="rect">
             <a:avLst/>
@@ -6729,7 +6731,7 @@
                 <a:ea typeface="Verdana" pitchFamily="34" charset="-122"/>
                 <a:cs typeface="Verdana" pitchFamily="34" charset="-120"/>
               </a:rPr>
-              <a:t>de evasão no ensino superior brasileiro</a:t>
+              <a:t>de desistência acumulada na rede privada, no ciclo 2020–2024</a:t>
             </a:r>
             <a:endParaRPr lang="en-US" sz="1100" dirty="0"/>
           </a:p>
@@ -6743,8 +6745,8 @@
         </p:nvSpPr>
         <p:spPr>
           <a:xfrm>
-            <a:off x="3429000" y="3200400"/>
-            <a:ext cx="2560320" cy="1737360"/>
+            <a:off x="4343400" y="3200400"/>
+            <a:ext cx="3474720" cy="1737360"/>
           </a:xfrm>
           <a:prstGeom prst="roundRect">
             <a:avLst>
@@ -6770,8 +6772,8 @@
         </p:nvSpPr>
         <p:spPr>
           <a:xfrm>
-            <a:off x="3429000" y="3401568"/>
-            <a:ext cx="2560320" cy="777240"/>
+            <a:off x="4343400" y="3401568"/>
+            <a:ext cx="3474720" cy="777240"/>
           </a:xfrm>
           <a:prstGeom prst="rect">
             <a:avLst/>
@@ -6795,7 +6797,7 @@
                 <a:ea typeface="Verdana" pitchFamily="34" charset="-122"/>
                 <a:cs typeface="Verdana" pitchFamily="34" charset="-120"/>
               </a:rPr>
-              <a:t>~61%</a:t>
+              <a:t>68,1%</a:t>
             </a:r>
             <a:endParaRPr lang="en-US" sz="3400" dirty="0"/>
           </a:p>
@@ -6809,8 +6811,8 @@
         </p:nvSpPr>
         <p:spPr>
           <a:xfrm>
-            <a:off x="3566160" y="4187952"/>
-            <a:ext cx="2286000" cy="640080"/>
+            <a:off x="4480560" y="4187952"/>
+            <a:ext cx="3200400" cy="640080"/>
           </a:xfrm>
           <a:prstGeom prst="rect">
             <a:avLst/>
@@ -6834,7 +6836,7 @@
                 <a:ea typeface="Verdana" pitchFamily="34" charset="-122"/>
                 <a:cs typeface="Verdana" pitchFamily="34" charset="-120"/>
               </a:rPr>
-              <a:t>na rede privada, 64% no ensino a distância</a:t>
+              <a:t>de desistência acumulada no EAD privado, no ciclo 2020–2024</a:t>
             </a:r>
             <a:endParaRPr lang="en-US" sz="1100" dirty="0"/>
           </a:p>
@@ -6848,8 +6850,8 @@
         </p:nvSpPr>
         <p:spPr>
           <a:xfrm>
-            <a:off x="6217920" y="3200400"/>
-            <a:ext cx="2560320" cy="1737360"/>
+            <a:off x="8046720" y="3200400"/>
+            <a:ext cx="3474720" cy="1737360"/>
           </a:xfrm>
           <a:prstGeom prst="roundRect">
             <a:avLst>
@@ -6875,8 +6877,8 @@
         </p:nvSpPr>
         <p:spPr>
           <a:xfrm>
-            <a:off x="6217920" y="3401568"/>
-            <a:ext cx="2560320" cy="777240"/>
+            <a:off x="8046720" y="3401568"/>
+            <a:ext cx="3474720" cy="777240"/>
           </a:xfrm>
           <a:prstGeom prst="rect">
             <a:avLst/>
@@ -6894,13 +6896,13 @@
             <a:r>
               <a:rPr lang="en-US" sz="3400" b="1" dirty="0">
                 <a:solidFill>
-                  <a:srgbClr val="D9A015"/>
-                </a:solidFill>
-                <a:latin typeface="Verdana" pitchFamily="34" charset="0"/>
-                <a:ea typeface="Verdana" pitchFamily="34" charset="-122"/>
-                <a:cs typeface="Verdana" pitchFamily="34" charset="-120"/>
-              </a:rPr>
-              <a:t>1 em 4</a:t>
+                  <a:srgbClr val="45BD8A"/>
+                </a:solidFill>
+                <a:latin typeface="Verdana" pitchFamily="34" charset="0"/>
+                <a:ea typeface="Verdana" pitchFamily="34" charset="-122"/>
+                <a:cs typeface="Verdana" pitchFamily="34" charset="-120"/>
+              </a:rPr>
+              <a:t>49%</a:t>
             </a:r>
             <a:endParaRPr lang="en-US" sz="3400" dirty="0"/>
           </a:p>
@@ -6914,8 +6916,8 @@
         </p:nvSpPr>
         <p:spPr>
           <a:xfrm>
-            <a:off x="6355080" y="4187952"/>
-            <a:ext cx="2286000" cy="640080"/>
+            <a:off x="8183880" y="4187952"/>
+            <a:ext cx="3200400" cy="640080"/>
           </a:xfrm>
           <a:prstGeom prst="rect">
             <a:avLst/>
@@ -6939,7 +6941,7 @@
                 <a:ea typeface="Verdana" pitchFamily="34" charset="-122"/>
                 <a:cs typeface="Verdana" pitchFamily="34" charset="-120"/>
               </a:rPr>
-              <a:t>jovens conclui a graduação que iniciou</a:t>
+              <a:t>dos ingressantes em bacharelados no Brasil concluem até três anos após a duração prevista</a:t>
             </a:r>
             <a:endParaRPr lang="en-US" sz="1100" dirty="0"/>
           </a:p>
@@ -6947,119 +6949,14 @@
       </p:sp>
       <p:sp>
         <p:nvSpPr>
-          <p:cNvPr id="14" name="Shape 12"/>
-          <p:cNvSpPr/>
-          <p:nvPr/>
-        </p:nvSpPr>
-        <p:spPr>
-          <a:xfrm>
-            <a:off x="9006840" y="3200400"/>
-            <a:ext cx="2560320" cy="1737360"/>
-          </a:xfrm>
-          <a:prstGeom prst="roundRect">
-            <a:avLst>
-              <a:gd name="adj" fmla="val 4211"/>
-            </a:avLst>
-          </a:prstGeom>
-          <a:solidFill>
-            <a:srgbClr val="141B26"/>
-          </a:solidFill>
-          <a:ln w="12700">
-            <a:solidFill>
-              <a:srgbClr val="2B3849"/>
-            </a:solidFill>
-            <a:prstDash val="solid"/>
-          </a:ln>
-        </p:spPr>
-      </p:sp>
-      <p:sp>
-        <p:nvSpPr>
-          <p:cNvPr id="15" name="Text 13"/>
-          <p:cNvSpPr/>
-          <p:nvPr/>
-        </p:nvSpPr>
-        <p:spPr>
-          <a:xfrm>
-            <a:off x="9006840" y="3401568"/>
-            <a:ext cx="2560320" cy="777240"/>
-          </a:xfrm>
-          <a:prstGeom prst="rect">
-            <a:avLst/>
-          </a:prstGeom>
-          <a:noFill/>
-          <a:ln/>
-        </p:spPr>
-        <p:txBody>
-          <a:bodyPr wrap="square" rtlCol="0" anchor="ctr"/>
-          <a:lstStyle/>
-          <a:p>
-            <a:pPr algn="ctr" indent="0" marL="0">
-              <a:buNone/>
-            </a:pPr>
-            <a:r>
-              <a:rPr lang="en-US" sz="3400" b="1" dirty="0">
-                <a:solidFill>
-                  <a:srgbClr val="45BD8A"/>
-                </a:solidFill>
-                <a:latin typeface="Verdana" pitchFamily="34" charset="0"/>
-                <a:ea typeface="Verdana" pitchFamily="34" charset="-122"/>
-                <a:cs typeface="Verdana" pitchFamily="34" charset="-120"/>
-              </a:rPr>
-              <a:t>semanas</a:t>
-            </a:r>
-            <a:endParaRPr lang="en-US" sz="3400" dirty="0"/>
-          </a:p>
-        </p:txBody>
-      </p:sp>
-      <p:sp>
-        <p:nvSpPr>
-          <p:cNvPr id="16" name="Text 14"/>
-          <p:cNvSpPr/>
-          <p:nvPr/>
-        </p:nvSpPr>
-        <p:spPr>
-          <a:xfrm>
-            <a:off x="9144000" y="4187952"/>
-            <a:ext cx="2286000" cy="640080"/>
-          </a:xfrm>
-          <a:prstGeom prst="rect">
-            <a:avLst/>
-          </a:prstGeom>
-          <a:noFill/>
-          <a:ln/>
-        </p:spPr>
-        <p:txBody>
-          <a:bodyPr wrap="square" rtlCol="0" anchor="ctr"/>
-          <a:lstStyle/>
-          <a:p>
-            <a:pPr algn="ctr" indent="0" marL="0">
-              <a:buNone/>
-            </a:pPr>
-            <a:r>
-              <a:rPr lang="en-US" sz="1100" dirty="0">
-                <a:solidFill>
-                  <a:srgbClr val="9FADBE"/>
-                </a:solidFill>
-                <a:latin typeface="Verdana" pitchFamily="34" charset="0"/>
-                <a:ea typeface="Verdana" pitchFamily="34" charset="-122"/>
-                <a:cs typeface="Verdana" pitchFamily="34" charset="-120"/>
-              </a:rPr>
-              <a:t>de antecedência entre sumir e a nota cair</a:t>
-            </a:r>
-            <a:endParaRPr lang="en-US" sz="1100" dirty="0"/>
-          </a:p>
-        </p:txBody>
-      </p:sp>
-      <p:sp>
-        <p:nvSpPr>
-          <p:cNvPr id="17" name="Text 15"/>
+          <p:cNvPr id="14" name="Text 12"/>
           <p:cNvSpPr/>
           <p:nvPr/>
         </p:nvSpPr>
         <p:spPr>
           <a:xfrm>
             <a:off x="640080" y="5257800"/>
-            <a:ext cx="10972800" cy="365760"/>
+            <a:ext cx="10972800" cy="594360"/>
           </a:xfrm>
           <a:prstGeom prst="rect">
             <a:avLst/>
@@ -7083,7 +6980,7 @@
                 <a:ea typeface="Verdana" pitchFamily="34" charset="-122"/>
                 <a:cs typeface="Verdana" pitchFamily="34" charset="-120"/>
               </a:rPr>
-              <a:t>Fontes: Mapa do Ensino Superior 2024 e 2026, Instituto Semesp; OCDE, Education at a Glance 2025.</a:t>
+              <a:t>Fontes: Semesp, Mapa do Ensino Superior 2026 (trajetória 2020–2024); OCDE, Education at a Glance 2025, Brasil, tabela B5.1.</a:t>
             </a:r>
             <a:endParaRPr lang="en-US" sz="1000" dirty="0"/>
           </a:p>
@@ -7091,7 +6988,7 @@
       </p:sp>
       <p:sp>
         <p:nvSpPr>
-          <p:cNvPr id="18" name="Text 16"/>
+          <p:cNvPr id="16" name="Text 13"/>
           <p:cNvSpPr/>
           <p:nvPr/>
         </p:nvSpPr>
@@ -7130,7 +7027,7 @@
       </p:sp>
       <p:sp>
         <p:nvSpPr>
-          <p:cNvPr id="19" name="Text 17"/>
+          <p:cNvPr id="17" name="Text 14"/>
           <p:cNvSpPr/>
           <p:nvPr/>
         </p:nvSpPr>
@@ -7772,7 +7669,7 @@
                 <a:ea typeface="Verdana" pitchFamily="34" charset="-122"/>
                 <a:cs typeface="Verdana" pitchFamily="34" charset="-120"/>
               </a:rPr>
-              <a:t>O CASO QUE JUSTIFICA O PROJETO</a:t>
+              <a:t>EXEMPLO SINTÉTICO</a:t>
             </a:r>
             <a:endParaRPr lang="en-US" sz="1100" dirty="0"/>
           </a:p>
@@ -7811,7 +7708,7 @@
                 <a:ea typeface="Verdana" pitchFamily="34" charset="-122"/>
                 <a:cs typeface="Verdana" pitchFamily="34" charset="-120"/>
               </a:rPr>
-              <a:t>O aluno que o critério da secretaria não enxerga</a:t>
+              <a:t>Um alerta além da média de notas</a:t>
             </a:r>
             <a:endParaRPr lang="en-US" sz="2800" dirty="0"/>
           </a:p>
@@ -9527,7 +9424,7 @@
                 <a:ea typeface="Verdana" pitchFamily="34" charset="-122"/>
                 <a:cs typeface="Verdana" pitchFamily="34" charset="-120"/>
               </a:rPr>
-              <a:t>A linha do meio é o projeto inteiro. Um critério baseado na média de notas classifica esse aluno como tranquilo. O sistema fuzzy o coloca em risco alto, e a regra 8 explica por quê: bom desempenho não anula a ausência sistemática das aulas, o histórico apenas atrasa o efeito na média.</a:t>
+              <a:t>A referência simplificada por nota não sinaliza o caso da linha do meio. A regra fuzzy combina baixa frequência e poucos acessos, mesmo com nota alta. O exemplo mostra a diferença entre os critérios; não prova que algum deles prevê evasão real.</a:t>
             </a:r>
             <a:endParaRPr lang="en-US" sz="1400" dirty="0"/>
           </a:p>
@@ -12381,7 +12278,7 @@
                 <a:ea typeface="Verdana" pitchFamily="34" charset="-122"/>
                 <a:cs typeface="Verdana" pitchFamily="34" charset="-120"/>
               </a:rPr>
-              <a:t>VISÃO CRÍTICA</a:t>
+              <a:t>RESULTADOS HISTÓRICOS DA BATERIA</a:t>
             </a:r>
             <a:endParaRPr lang="en-US" sz="1100" dirty="0"/>
           </a:p>
@@ -12420,7 +12317,7 @@
                 <a:ea typeface="Verdana" pitchFamily="34" charset="-122"/>
                 <a:cs typeface="Verdana" pitchFamily="34" charset="-120"/>
               </a:rPr>
-              <a:t>O que medimos, e o que não conseguimos resolver</a:t>
+              <a:t>Métricas com escopo limitado</a:t>
             </a:r>
             <a:endParaRPr lang="en-US" sz="2800" dirty="0"/>
           </a:p>
@@ -12948,7 +12845,7 @@
                 <a:ea typeface="Verdana" pitchFamily="34" charset="-122"/>
                 <a:cs typeface="Verdana" pitchFamily="34" charset="-120"/>
               </a:rPr>
-              <a:t>O maior risco deste sistema não é inventar uma data. É repetir com confiança a data certa de uma ementa do semestre passado. O RAG resolve alucinação, não desatualização.</a:t>
+              <a:t>Esses resultados correspondem às configurações registradas em AVALIACAO-RAG.md e não garantem o desempenho de novas versões. O RAG pode gerar respostas incorretas ou usar documentos desatualizados.</a:t>
             </a:r>
             <a:endParaRPr lang="en-US" sz="1250" dirty="0"/>
           </a:p>
@@ -12977,7 +12874,7 @@
                 <a:ea typeface="Verdana" pitchFamily="34" charset="-122"/>
                 <a:cs typeface="Verdana" pitchFamily="34" charset="-120"/>
               </a:rPr>
-              <a:t>A mitigação é parcial: todo documento carrega uma referência de data que aparece em toda citação. Uma solução real exigiria integração com o sistema acadêmico.</a:t>
+              <a:t>A referência de data ajuda a revisão, mas não prova atualidade nem fidelidade de toda a resposta. O score fuzzy ainda exige avaliação com dados reais.</a:t>
             </a:r>
             <a:endParaRPr lang="en-US" sz="1250" dirty="0"/>
           </a:p>

</xml_diff>

<commit_message>
fix: reforça sessões, privacidade e rastreabilidade acadêmica (#1)
* fix(seguranca): revoga sessões e isola o histórico por usuário

* docs(pesquisa): corrige indicadores e delimita evidências acadêmicas

* fix(banco): permite aplicar a migração inicial em uma base vazia

* fix(rag): limita consultas e endurece avaliação
</commit_message>
<xml_diff>
--- a/PermaneIA-Apresentacao.pptx
+++ b/PermaneIA-Apresentacao.pptx
@@ -1043,7 +1043,9 @@
           <a:p>
             <a:r>
               <a:rPr lang="en-US" dirty="0"/>
-              <a:t/>
+              <a:t>64,7%: de desistência acumulada na rede privada, no ciclo 2020–2024. Instituto Semesp, Mapa do Ensino Superior 2026. Indicadores de trajetória, base Inep. https://www.semesp.org.br/mapa/edicao-16/brasil/
+68,1%: de desistência acumulada no EAD privado, no ciclo 2020–2024. Instituto Semesp, Mapa do Ensino Superior 2026. Indicadores de trajetória, base Inep. https://www.semesp.org.br/mapa/edicao-16/brasil/
+49%: dos ingressantes em bacharelados no Brasil concluem até três anos após a duração prevista. OCDE, Education at a Glance 2025, nota do Brasil, tabela B5.1. https://www.oecd.org/en/publications/education-at-a-glance-2025_1a3543e2-en/brazil_d42263a0-en.html</a:t>
             </a:r>
             <a:endParaRPr lang="en-US" dirty="0"/>
           </a:p>
@@ -6582,7 +6584,7 @@
                 <a:ea typeface="Verdana" pitchFamily="34" charset="-122"/>
                 <a:cs typeface="Verdana" pitchFamily="34" charset="-120"/>
               </a:rPr>
-              <a:t>Mais da metade não termina o que começou</a:t>
+              <a:t>Permanência exige acompanhamento</a:t>
             </a:r>
             <a:endParaRPr lang="en-US" sz="2800" dirty="0"/>
           </a:p>
@@ -6624,7 +6626,7 @@
                 <a:ea typeface="Verdana" pitchFamily="34" charset="-122"/>
                 <a:cs typeface="Verdana" pitchFamily="34" charset="-120"/>
               </a:rPr>
-              <a:t>A evasão no ensino superior brasileiro não é um risco distante: é o desfecho mais provável para boa parte de quem entra. E o abandono não começa quando a nota cai. Começa quando o aluno para de aparecer.</a:t>
+              <a:t>Os indicadores abaixo usam populações e períodos diferentes. Eles contextualizam o problema; não medem a eficácia do PermaneIA. O alerta fuzzy é uma heurística acadêmica, ainda sem validação preditiva com alunos reais.</a:t>
             </a:r>
             <a:endParaRPr lang="en-US" sz="1500" dirty="0"/>
           </a:p>
@@ -6639,7 +6641,7 @@
         <p:spPr>
           <a:xfrm>
             <a:off x="640080" y="3200400"/>
-            <a:ext cx="2560320" cy="1737360"/>
+            <a:ext cx="3474720" cy="1737360"/>
           </a:xfrm>
           <a:prstGeom prst="roundRect">
             <a:avLst>
@@ -6666,7 +6668,7 @@
         <p:spPr>
           <a:xfrm>
             <a:off x="640080" y="3401568"/>
-            <a:ext cx="2560320" cy="777240"/>
+            <a:ext cx="3474720" cy="777240"/>
           </a:xfrm>
           <a:prstGeom prst="rect">
             <a:avLst/>
@@ -6690,7 +6692,7 @@
                 <a:ea typeface="Verdana" pitchFamily="34" charset="-122"/>
                 <a:cs typeface="Verdana" pitchFamily="34" charset="-120"/>
               </a:rPr>
-              <a:t>57,2%</a:t>
+              <a:t>64,7%</a:t>
             </a:r>
             <a:endParaRPr lang="en-US" sz="3400" dirty="0"/>
           </a:p>
@@ -6705,7 +6707,7 @@
         <p:spPr>
           <a:xfrm>
             <a:off x="777240" y="4187952"/>
-            <a:ext cx="2286000" cy="640080"/>
+            <a:ext cx="3200400" cy="640080"/>
           </a:xfrm>
           <a:prstGeom prst="rect">
             <a:avLst/>
@@ -6729,7 +6731,7 @@
                 <a:ea typeface="Verdana" pitchFamily="34" charset="-122"/>
                 <a:cs typeface="Verdana" pitchFamily="34" charset="-120"/>
               </a:rPr>
-              <a:t>de evasão no ensino superior brasileiro</a:t>
+              <a:t>de desistência acumulada na rede privada, no ciclo 2020–2024</a:t>
             </a:r>
             <a:endParaRPr lang="en-US" sz="1100" dirty="0"/>
           </a:p>
@@ -6743,8 +6745,8 @@
         </p:nvSpPr>
         <p:spPr>
           <a:xfrm>
-            <a:off x="3429000" y="3200400"/>
-            <a:ext cx="2560320" cy="1737360"/>
+            <a:off x="4343400" y="3200400"/>
+            <a:ext cx="3474720" cy="1737360"/>
           </a:xfrm>
           <a:prstGeom prst="roundRect">
             <a:avLst>
@@ -6770,8 +6772,8 @@
         </p:nvSpPr>
         <p:spPr>
           <a:xfrm>
-            <a:off x="3429000" y="3401568"/>
-            <a:ext cx="2560320" cy="777240"/>
+            <a:off x="4343400" y="3401568"/>
+            <a:ext cx="3474720" cy="777240"/>
           </a:xfrm>
           <a:prstGeom prst="rect">
             <a:avLst/>
@@ -6795,7 +6797,7 @@
                 <a:ea typeface="Verdana" pitchFamily="34" charset="-122"/>
                 <a:cs typeface="Verdana" pitchFamily="34" charset="-120"/>
               </a:rPr>
-              <a:t>~61%</a:t>
+              <a:t>68,1%</a:t>
             </a:r>
             <a:endParaRPr lang="en-US" sz="3400" dirty="0"/>
           </a:p>
@@ -6809,8 +6811,8 @@
         </p:nvSpPr>
         <p:spPr>
           <a:xfrm>
-            <a:off x="3566160" y="4187952"/>
-            <a:ext cx="2286000" cy="640080"/>
+            <a:off x="4480560" y="4187952"/>
+            <a:ext cx="3200400" cy="640080"/>
           </a:xfrm>
           <a:prstGeom prst="rect">
             <a:avLst/>
@@ -6834,7 +6836,7 @@
                 <a:ea typeface="Verdana" pitchFamily="34" charset="-122"/>
                 <a:cs typeface="Verdana" pitchFamily="34" charset="-120"/>
               </a:rPr>
-              <a:t>na rede privada, 64% no ensino a distância</a:t>
+              <a:t>de desistência acumulada no EAD privado, no ciclo 2020–2024</a:t>
             </a:r>
             <a:endParaRPr lang="en-US" sz="1100" dirty="0"/>
           </a:p>
@@ -6848,8 +6850,8 @@
         </p:nvSpPr>
         <p:spPr>
           <a:xfrm>
-            <a:off x="6217920" y="3200400"/>
-            <a:ext cx="2560320" cy="1737360"/>
+            <a:off x="8046720" y="3200400"/>
+            <a:ext cx="3474720" cy="1737360"/>
           </a:xfrm>
           <a:prstGeom prst="roundRect">
             <a:avLst>
@@ -6875,8 +6877,8 @@
         </p:nvSpPr>
         <p:spPr>
           <a:xfrm>
-            <a:off x="6217920" y="3401568"/>
-            <a:ext cx="2560320" cy="777240"/>
+            <a:off x="8046720" y="3401568"/>
+            <a:ext cx="3474720" cy="777240"/>
           </a:xfrm>
           <a:prstGeom prst="rect">
             <a:avLst/>
@@ -6894,13 +6896,13 @@
             <a:r>
               <a:rPr lang="en-US" sz="3400" b="1" dirty="0">
                 <a:solidFill>
-                  <a:srgbClr val="D9A015"/>
-                </a:solidFill>
-                <a:latin typeface="Verdana" pitchFamily="34" charset="0"/>
-                <a:ea typeface="Verdana" pitchFamily="34" charset="-122"/>
-                <a:cs typeface="Verdana" pitchFamily="34" charset="-120"/>
-              </a:rPr>
-              <a:t>1 em 4</a:t>
+                  <a:srgbClr val="45BD8A"/>
+                </a:solidFill>
+                <a:latin typeface="Verdana" pitchFamily="34" charset="0"/>
+                <a:ea typeface="Verdana" pitchFamily="34" charset="-122"/>
+                <a:cs typeface="Verdana" pitchFamily="34" charset="-120"/>
+              </a:rPr>
+              <a:t>49%</a:t>
             </a:r>
             <a:endParaRPr lang="en-US" sz="3400" dirty="0"/>
           </a:p>
@@ -6914,8 +6916,8 @@
         </p:nvSpPr>
         <p:spPr>
           <a:xfrm>
-            <a:off x="6355080" y="4187952"/>
-            <a:ext cx="2286000" cy="640080"/>
+            <a:off x="8183880" y="4187952"/>
+            <a:ext cx="3200400" cy="640080"/>
           </a:xfrm>
           <a:prstGeom prst="rect">
             <a:avLst/>
@@ -6939,7 +6941,7 @@
                 <a:ea typeface="Verdana" pitchFamily="34" charset="-122"/>
                 <a:cs typeface="Verdana" pitchFamily="34" charset="-120"/>
               </a:rPr>
-              <a:t>jovens conclui a graduação que iniciou</a:t>
+              <a:t>dos ingressantes em bacharelados no Brasil concluem até três anos após a duração prevista</a:t>
             </a:r>
             <a:endParaRPr lang="en-US" sz="1100" dirty="0"/>
           </a:p>
@@ -6947,119 +6949,14 @@
       </p:sp>
       <p:sp>
         <p:nvSpPr>
-          <p:cNvPr id="14" name="Shape 12"/>
-          <p:cNvSpPr/>
-          <p:nvPr/>
-        </p:nvSpPr>
-        <p:spPr>
-          <a:xfrm>
-            <a:off x="9006840" y="3200400"/>
-            <a:ext cx="2560320" cy="1737360"/>
-          </a:xfrm>
-          <a:prstGeom prst="roundRect">
-            <a:avLst>
-              <a:gd name="adj" fmla="val 4211"/>
-            </a:avLst>
-          </a:prstGeom>
-          <a:solidFill>
-            <a:srgbClr val="141B26"/>
-          </a:solidFill>
-          <a:ln w="12700">
-            <a:solidFill>
-              <a:srgbClr val="2B3849"/>
-            </a:solidFill>
-            <a:prstDash val="solid"/>
-          </a:ln>
-        </p:spPr>
-      </p:sp>
-      <p:sp>
-        <p:nvSpPr>
-          <p:cNvPr id="15" name="Text 13"/>
-          <p:cNvSpPr/>
-          <p:nvPr/>
-        </p:nvSpPr>
-        <p:spPr>
-          <a:xfrm>
-            <a:off x="9006840" y="3401568"/>
-            <a:ext cx="2560320" cy="777240"/>
-          </a:xfrm>
-          <a:prstGeom prst="rect">
-            <a:avLst/>
-          </a:prstGeom>
-          <a:noFill/>
-          <a:ln/>
-        </p:spPr>
-        <p:txBody>
-          <a:bodyPr wrap="square" rtlCol="0" anchor="ctr"/>
-          <a:lstStyle/>
-          <a:p>
-            <a:pPr algn="ctr" indent="0" marL="0">
-              <a:buNone/>
-            </a:pPr>
-            <a:r>
-              <a:rPr lang="en-US" sz="3400" b="1" dirty="0">
-                <a:solidFill>
-                  <a:srgbClr val="45BD8A"/>
-                </a:solidFill>
-                <a:latin typeface="Verdana" pitchFamily="34" charset="0"/>
-                <a:ea typeface="Verdana" pitchFamily="34" charset="-122"/>
-                <a:cs typeface="Verdana" pitchFamily="34" charset="-120"/>
-              </a:rPr>
-              <a:t>semanas</a:t>
-            </a:r>
-            <a:endParaRPr lang="en-US" sz="3400" dirty="0"/>
-          </a:p>
-        </p:txBody>
-      </p:sp>
-      <p:sp>
-        <p:nvSpPr>
-          <p:cNvPr id="16" name="Text 14"/>
-          <p:cNvSpPr/>
-          <p:nvPr/>
-        </p:nvSpPr>
-        <p:spPr>
-          <a:xfrm>
-            <a:off x="9144000" y="4187952"/>
-            <a:ext cx="2286000" cy="640080"/>
-          </a:xfrm>
-          <a:prstGeom prst="rect">
-            <a:avLst/>
-          </a:prstGeom>
-          <a:noFill/>
-          <a:ln/>
-        </p:spPr>
-        <p:txBody>
-          <a:bodyPr wrap="square" rtlCol="0" anchor="ctr"/>
-          <a:lstStyle/>
-          <a:p>
-            <a:pPr algn="ctr" indent="0" marL="0">
-              <a:buNone/>
-            </a:pPr>
-            <a:r>
-              <a:rPr lang="en-US" sz="1100" dirty="0">
-                <a:solidFill>
-                  <a:srgbClr val="9FADBE"/>
-                </a:solidFill>
-                <a:latin typeface="Verdana" pitchFamily="34" charset="0"/>
-                <a:ea typeface="Verdana" pitchFamily="34" charset="-122"/>
-                <a:cs typeface="Verdana" pitchFamily="34" charset="-120"/>
-              </a:rPr>
-              <a:t>de antecedência entre sumir e a nota cair</a:t>
-            </a:r>
-            <a:endParaRPr lang="en-US" sz="1100" dirty="0"/>
-          </a:p>
-        </p:txBody>
-      </p:sp>
-      <p:sp>
-        <p:nvSpPr>
-          <p:cNvPr id="17" name="Text 15"/>
+          <p:cNvPr id="14" name="Text 12"/>
           <p:cNvSpPr/>
           <p:nvPr/>
         </p:nvSpPr>
         <p:spPr>
           <a:xfrm>
             <a:off x="640080" y="5257800"/>
-            <a:ext cx="10972800" cy="365760"/>
+            <a:ext cx="10972800" cy="594360"/>
           </a:xfrm>
           <a:prstGeom prst="rect">
             <a:avLst/>
@@ -7083,7 +6980,7 @@
                 <a:ea typeface="Verdana" pitchFamily="34" charset="-122"/>
                 <a:cs typeface="Verdana" pitchFamily="34" charset="-120"/>
               </a:rPr>
-              <a:t>Fontes: Mapa do Ensino Superior 2024 e 2026, Instituto Semesp; OCDE, Education at a Glance 2025.</a:t>
+              <a:t>Fontes: Semesp, Mapa do Ensino Superior 2026 (trajetória 2020–2024); OCDE, Education at a Glance 2025, Brasil, tabela B5.1.</a:t>
             </a:r>
             <a:endParaRPr lang="en-US" sz="1000" dirty="0"/>
           </a:p>
@@ -7091,7 +6988,7 @@
       </p:sp>
       <p:sp>
         <p:nvSpPr>
-          <p:cNvPr id="18" name="Text 16"/>
+          <p:cNvPr id="16" name="Text 13"/>
           <p:cNvSpPr/>
           <p:nvPr/>
         </p:nvSpPr>
@@ -7130,7 +7027,7 @@
       </p:sp>
       <p:sp>
         <p:nvSpPr>
-          <p:cNvPr id="19" name="Text 17"/>
+          <p:cNvPr id="17" name="Text 14"/>
           <p:cNvSpPr/>
           <p:nvPr/>
         </p:nvSpPr>
@@ -7772,7 +7669,7 @@
                 <a:ea typeface="Verdana" pitchFamily="34" charset="-122"/>
                 <a:cs typeface="Verdana" pitchFamily="34" charset="-120"/>
               </a:rPr>
-              <a:t>O CASO QUE JUSTIFICA O PROJETO</a:t>
+              <a:t>EXEMPLO SINTÉTICO</a:t>
             </a:r>
             <a:endParaRPr lang="en-US" sz="1100" dirty="0"/>
           </a:p>
@@ -7811,7 +7708,7 @@
                 <a:ea typeface="Verdana" pitchFamily="34" charset="-122"/>
                 <a:cs typeface="Verdana" pitchFamily="34" charset="-120"/>
               </a:rPr>
-              <a:t>O aluno que o critério da secretaria não enxerga</a:t>
+              <a:t>Um alerta além da média de notas</a:t>
             </a:r>
             <a:endParaRPr lang="en-US" sz="2800" dirty="0"/>
           </a:p>
@@ -9527,7 +9424,7 @@
                 <a:ea typeface="Verdana" pitchFamily="34" charset="-122"/>
                 <a:cs typeface="Verdana" pitchFamily="34" charset="-120"/>
               </a:rPr>
-              <a:t>A linha do meio é o projeto inteiro. Um critério baseado na média de notas classifica esse aluno como tranquilo. O sistema fuzzy o coloca em risco alto, e a regra 8 explica por quê: bom desempenho não anula a ausência sistemática das aulas, o histórico apenas atrasa o efeito na média.</a:t>
+              <a:t>A referência simplificada por nota não sinaliza o caso da linha do meio. A regra fuzzy combina baixa frequência e poucos acessos, mesmo com nota alta. O exemplo mostra a diferença entre os critérios; não prova que algum deles prevê evasão real.</a:t>
             </a:r>
             <a:endParaRPr lang="en-US" sz="1400" dirty="0"/>
           </a:p>
@@ -12381,7 +12278,7 @@
                 <a:ea typeface="Verdana" pitchFamily="34" charset="-122"/>
                 <a:cs typeface="Verdana" pitchFamily="34" charset="-120"/>
               </a:rPr>
-              <a:t>VISÃO CRÍTICA</a:t>
+              <a:t>RESULTADOS HISTÓRICOS DA BATERIA</a:t>
             </a:r>
             <a:endParaRPr lang="en-US" sz="1100" dirty="0"/>
           </a:p>
@@ -12420,7 +12317,7 @@
                 <a:ea typeface="Verdana" pitchFamily="34" charset="-122"/>
                 <a:cs typeface="Verdana" pitchFamily="34" charset="-120"/>
               </a:rPr>
-              <a:t>O que medimos, e o que não conseguimos resolver</a:t>
+              <a:t>Métricas com escopo limitado</a:t>
             </a:r>
             <a:endParaRPr lang="en-US" sz="2800" dirty="0"/>
           </a:p>
@@ -12948,7 +12845,7 @@
                 <a:ea typeface="Verdana" pitchFamily="34" charset="-122"/>
                 <a:cs typeface="Verdana" pitchFamily="34" charset="-120"/>
               </a:rPr>
-              <a:t>O maior risco deste sistema não é inventar uma data. É repetir com confiança a data certa de uma ementa do semestre passado. O RAG resolve alucinação, não desatualização.</a:t>
+              <a:t>Esses resultados correspondem às configurações registradas em AVALIACAO-RAG.md e não garantem o desempenho de novas versões. O RAG pode gerar respostas incorretas ou usar documentos desatualizados.</a:t>
             </a:r>
             <a:endParaRPr lang="en-US" sz="1250" dirty="0"/>
           </a:p>
@@ -12977,7 +12874,7 @@
                 <a:ea typeface="Verdana" pitchFamily="34" charset="-122"/>
                 <a:cs typeface="Verdana" pitchFamily="34" charset="-120"/>
               </a:rPr>
-              <a:t>A mitigação é parcial: todo documento carrega uma referência de data que aparece em toda citação. Uma solução real exigiria integração com o sistema acadêmico.</a:t>
+              <a:t>A referência de data ajuda a revisão, mas não prova atualidade nem fidelidade de toda a resposta. O score fuzzy ainda exige avaliação com dados reais.</a:t>
             </a:r>
             <a:endParaRPr lang="en-US" sz="1250" dirty="0"/>
           </a:p>

</xml_diff>